<commit_message>
docs(toss): update payment-path deck for guest checkout
- ④ 로그인/회원가입 → "비회원 구매 경로" (로그인 불필요)
- 유의사항·표지·회신요약에서 테스트 계정 문구 제거
- 구매과정에 우편번호 검색(Daum) 항목 추가
</commit_message>
<xml_diff>
--- a/docs/toss/DoLF_결제경로_초안.pptx
+++ b/docs/toss/DoLF_결제경로_초안.pptx
@@ -2127,7 +2127,7 @@
                 <a:ea typeface="Malgun Gothic" pitchFamily="34" charset="-122"/>
                 <a:cs typeface="Malgun Gothic" pitchFamily="34" charset="-120"/>
               </a:rPr>
-              <a:t>(6) Test ID</a:t>
+              <a:t>(6) 비회원 구매</a:t>
             </a:r>
             <a:endParaRPr lang="en-US" sz="1500" dirty="0"/>
           </a:p>
@@ -2166,7 +2166,7 @@
                 <a:ea typeface="Malgun Gothic" pitchFamily="34" charset="-122"/>
                 <a:cs typeface="Malgun Gothic" pitchFamily="34" charset="-120"/>
               </a:rPr>
-              <a:t>[테스트 계정 ID — 입력 필요]</a:t>
+              <a:t>가능 — 로그인 없이 결제 (테스트 계정 불필요)</a:t>
             </a:r>
             <a:endParaRPr lang="en-US" sz="1500" dirty="0"/>
           </a:p>
@@ -2175,84 +2175,6 @@
       <p:sp>
         <p:nvSpPr>
           <p:cNvPr id="17" name="Text 15"/>
-          <p:cNvSpPr/>
-          <p:nvPr/>
-        </p:nvSpPr>
-        <p:spPr>
-          <a:xfrm>
-            <a:off x="640080" y="5934456"/>
-            <a:ext cx="2834640" cy="310896"/>
-          </a:xfrm>
-          <a:prstGeom prst="rect">
-            <a:avLst/>
-          </a:prstGeom>
-          <a:noFill/>
-          <a:ln/>
-        </p:spPr>
-        <p:txBody>
-          <a:bodyPr wrap="square" rtlCol="0" anchor="ctr"/>
-          <a:lstStyle/>
-          <a:p>
-            <a:pPr indent="0" marL="0">
-              <a:buNone/>
-            </a:pPr>
-            <a:r>
-              <a:rPr lang="en-US" sz="1500" b="1" dirty="0">
-                <a:solidFill>
-                  <a:srgbClr val="CFCABF"/>
-                </a:solidFill>
-                <a:latin typeface="Malgun Gothic" pitchFamily="34" charset="0"/>
-                <a:ea typeface="Malgun Gothic" pitchFamily="34" charset="-122"/>
-                <a:cs typeface="Malgun Gothic" pitchFamily="34" charset="-120"/>
-              </a:rPr>
-              <a:t>(7) Test PW</a:t>
-            </a:r>
-            <a:endParaRPr lang="en-US" sz="1500" dirty="0"/>
-          </a:p>
-        </p:txBody>
-      </p:sp>
-      <p:sp>
-        <p:nvSpPr>
-          <p:cNvPr id="18" name="Text 16"/>
-          <p:cNvSpPr/>
-          <p:nvPr/>
-        </p:nvSpPr>
-        <p:spPr>
-          <a:xfrm>
-            <a:off x="3566160" y="5934456"/>
-            <a:ext cx="7985455" cy="310896"/>
-          </a:xfrm>
-          <a:prstGeom prst="rect">
-            <a:avLst/>
-          </a:prstGeom>
-          <a:noFill/>
-          <a:ln/>
-        </p:spPr>
-        <p:txBody>
-          <a:bodyPr wrap="square" rtlCol="0" anchor="ctr"/>
-          <a:lstStyle/>
-          <a:p>
-            <a:pPr indent="0" marL="0">
-              <a:buNone/>
-            </a:pPr>
-            <a:r>
-              <a:rPr lang="en-US" sz="1500" dirty="0">
-                <a:solidFill>
-                  <a:srgbClr val="FFFFFF"/>
-                </a:solidFill>
-                <a:latin typeface="Malgun Gothic" pitchFamily="34" charset="0"/>
-                <a:ea typeface="Malgun Gothic" pitchFamily="34" charset="-122"/>
-                <a:cs typeface="Malgun Gothic" pitchFamily="34" charset="-120"/>
-              </a:rPr>
-              <a:t>[테스트 계정 PW — 입력 필요]</a:t>
-            </a:r>
-            <a:endParaRPr lang="en-US" sz="1500" dirty="0"/>
-          </a:p>
-        </p:txBody>
-      </p:sp>
-      <p:sp>
-        <p:nvSpPr>
-          <p:cNvPr id="19" name="Text 17"/>
           <p:cNvSpPr/>
           <p:nvPr/>
         </p:nvSpPr>
@@ -2283,7 +2205,7 @@
                 <a:ea typeface="Malgun Gothic" pitchFamily="34" charset="-122"/>
                 <a:cs typeface="Malgun Gothic" pitchFamily="34" charset="-120"/>
               </a:rPr>
-              <a:t>작성일 2026-08-13 · 단위 KRW</a:t>
+              <a:t>작성일 2026-08-14 · 단위 KRW</a:t>
             </a:r>
             <a:endParaRPr lang="en-US" sz="1000" dirty="0"/>
           </a:p>
@@ -3098,7 +3020,7 @@
                 <a:ea typeface="Malgun Gothic" pitchFamily="34" charset="-122"/>
                 <a:cs typeface="Malgun Gothic" pitchFamily="34" charset="-120"/>
               </a:rPr>
-              <a:t>테스트 계정 필요</a:t>
+              <a:t>비회원 구매 가능</a:t>
             </a:r>
             <a:endParaRPr lang="en-US" sz="1500" dirty="0"/>
           </a:p>
@@ -3137,7 +3059,7 @@
                 <a:ea typeface="Malgun Gothic" pitchFamily="34" charset="-122"/>
                 <a:cs typeface="Malgun Gothic" pitchFamily="34" charset="-120"/>
               </a:rPr>
-              <a:t>본 사이트는 비회원 구매 불가(로그인 필수) → 테스트 계정 로그인 과정 캡처가 필요합니다.</a:t>
+              <a:t>로그인 없이 결제 가능 → 로그인/회원가입 대신 “비회원 구매 경로”를 캡처하면 됩니다.</a:t>
             </a:r>
             <a:endParaRPr lang="en-US" sz="1150" dirty="0"/>
           </a:p>
@@ -4865,7 +4787,7 @@
                 <a:ea typeface="Malgun Gothic" pitchFamily="34" charset="-122"/>
                 <a:cs typeface="Malgun Gothic" pitchFamily="34" charset="-120"/>
               </a:rPr>
-              <a:t>로그인 / 회원가입 경로</a:t>
+              <a:t>비회원 구매 경로</a:t>
             </a:r>
             <a:endParaRPr lang="en-US" sz="2400" dirty="0"/>
           </a:p>
@@ -4904,7 +4826,7 @@
                 <a:ea typeface="Malgun Gothic" pitchFamily="34" charset="-122"/>
                 <a:cs typeface="Malgun Gothic" pitchFamily="34" charset="-120"/>
               </a:rPr>
-              <a:t>본 사이트는 비회원 구매 불가 → 테스트 계정 로그인 과정 캡처 필요</a:t>
+              <a:t>로그인 없이 결제 가능 — 로그인/회원가입 대신 비회원 구매 경로를 캡처</a:t>
             </a:r>
             <a:endParaRPr lang="en-US" sz="1200" dirty="0"/>
           </a:p>
@@ -4968,7 +4890,7 @@
                 <a:ea typeface="Malgun Gothic" pitchFamily="34" charset="-122"/>
                 <a:cs typeface="Malgun Gothic" pitchFamily="34" charset="-120"/>
               </a:rPr>
-              <a:t>[로그인 페이지 캡처]</a:t>
+              <a:t>[체크아웃(주문서) 캡처]</a:t>
             </a:r>
             <a:endParaRPr lang="en-US" sz="1300" dirty="0"/>
           </a:p>
@@ -4985,7 +4907,7 @@
                 <a:ea typeface="Malgun Gothic" pitchFamily="34" charset="-122"/>
                 <a:cs typeface="Malgun Gothic" pitchFamily="34" charset="-120"/>
               </a:rPr>
-              <a:t>/signin · 아이디/비밀번호 입력 화면</a:t>
+              <a:t>“비회원 주문 · 로그인 없이 결제할 수 있어요” 배지가 보이도록</a:t>
             </a:r>
             <a:endParaRPr lang="en-US" sz="1300" dirty="0"/>
           </a:p>
@@ -5049,7 +4971,7 @@
                 <a:ea typeface="Malgun Gothic" pitchFamily="34" charset="-122"/>
                 <a:cs typeface="Malgun Gothic" pitchFamily="34" charset="-120"/>
               </a:rPr>
-              <a:t>[회원가입 페이지 캡처]</a:t>
+              <a:t>[상품 → 장바구니 → 결제하기 진입]</a:t>
             </a:r>
             <a:endParaRPr lang="en-US" sz="1300" dirty="0"/>
           </a:p>
@@ -5066,7 +4988,7 @@
                 <a:ea typeface="Malgun Gothic" pitchFamily="34" charset="-122"/>
                 <a:cs typeface="Malgun Gothic" pitchFamily="34" charset="-120"/>
               </a:rPr>
-              <a:t>/signup · 가입 폼 화면</a:t>
+              <a:t>로그인 요구 없이 결제로 넘어가는 흐름</a:t>
             </a:r>
             <a:endParaRPr lang="en-US" sz="1300" dirty="0"/>
           </a:p>
@@ -5119,7 +5041,7 @@
                 <a:ea typeface="Malgun Gothic" pitchFamily="34" charset="-122"/>
                 <a:cs typeface="Malgun Gothic" pitchFamily="34" charset="-120"/>
               </a:rPr>
-              <a:t>checkout(결제) 진입 시 로그인 필수입니다. 회신 메일에 테스트 계정 ID/PW를 함께 기재하고, 그 계정으로 로그인하는 과정을 캡처하세요. (소셜 로그인 계정 불가)</a:t>
+              <a:t>본 사이트는 비회원 구매가 가능합니다(로그인 불필요) → 로그인/회원가입 경로 대신 위 “비회원 구매 경로”를 캡처하면 됩니다. 회원 구매도 지원.</a:t>
             </a:r>
             <a:endParaRPr lang="en-US" sz="1200" dirty="0"/>
           </a:p>
@@ -6263,6 +6185,58 @@
                 <a:ea typeface="Malgun Gothic" pitchFamily="34" charset="-122"/>
                 <a:cs typeface="Malgun Gothic" pitchFamily="34" charset="-120"/>
               </a:rPr>
+              <a:t>주소 입력  </a:t>
+            </a:r>
+            <a:pPr indent="0" marL="0">
+              <a:lnSpc>
+                <a:spcPct val="135000"/>
+              </a:lnSpc>
+              <a:buNone/>
+            </a:pPr>
+            <a:r>
+              <a:rPr lang="en-US" sz="1250" dirty="0">
+                <a:solidFill>
+                  <a:srgbClr val="6B6B6E"/>
+                </a:solidFill>
+                <a:latin typeface="Malgun Gothic" pitchFamily="34" charset="0"/>
+                <a:ea typeface="Malgun Gothic" pitchFamily="34" charset="-122"/>
+                <a:cs typeface="Malgun Gothic" pitchFamily="34" charset="-120"/>
+              </a:rPr>
+              <a:t>우편번호 검색(Daum) 지원
+</a:t>
+            </a:r>
+            <a:pPr indent="0" marL="0">
+              <a:lnSpc>
+                <a:spcPct val="135000"/>
+              </a:lnSpc>
+              <a:buNone/>
+            </a:pPr>
+            <a:r>
+              <a:rPr lang="en-US" sz="1250" b="1" dirty="0">
+                <a:solidFill>
+                  <a:srgbClr val="A81212"/>
+                </a:solidFill>
+                <a:latin typeface="Malgun Gothic" pitchFamily="34" charset="0"/>
+                <a:ea typeface="Malgun Gothic" pitchFamily="34" charset="-122"/>
+                <a:cs typeface="Malgun Gothic" pitchFamily="34" charset="-120"/>
+              </a:rPr>
+              <a:t>✓ </a:t>
+            </a:r>
+            <a:pPr indent="0" marL="0">
+              <a:lnSpc>
+                <a:spcPct val="135000"/>
+              </a:lnSpc>
+              <a:buNone/>
+            </a:pPr>
+            <a:r>
+              <a:rPr lang="en-US" sz="1250" b="1" dirty="0">
+                <a:solidFill>
+                  <a:srgbClr val="1F1F21"/>
+                </a:solidFill>
+                <a:latin typeface="Malgun Gothic" pitchFamily="34" charset="0"/>
+                <a:ea typeface="Malgun Gothic" pitchFamily="34" charset="-122"/>
+                <a:cs typeface="Malgun Gothic" pitchFamily="34" charset="-120"/>
+              </a:rPr>
               <a:t>결제수단  </a:t>
             </a:r>
             <a:pPr indent="0" marL="0">
@@ -7269,7 +7243,7 @@
                 <a:ea typeface="Malgun Gothic" pitchFamily="34" charset="-122"/>
                 <a:cs typeface="Malgun Gothic" pitchFamily="34" charset="-120"/>
               </a:rPr>
-              <a:t>+ 테스트 계정 ID/PW</a:t>
+              <a:t>+ 비회원 구매</a:t>
             </a:r>
             <a:endParaRPr lang="en-US" sz="1300" dirty="0"/>
           </a:p>
@@ -7308,7 +7282,7 @@
                 <a:ea typeface="Malgun Gothic" pitchFamily="34" charset="-122"/>
                 <a:cs typeface="Malgun Gothic" pitchFamily="34" charset="-120"/>
               </a:rPr>
-              <a:t>[입력 필요] · 비회원 구매 불가(로그인 필수), 소셜 로그인 불가</a:t>
+              <a:t>가능 — 로그인 없이 결제 (테스트 계정 불필요)</a:t>
             </a:r>
             <a:endParaRPr lang="en-US" sz="1300" dirty="0"/>
           </a:p>
@@ -7581,7 +7555,7 @@
                 <a:ea typeface="Malgun Gothic" pitchFamily="34" charset="-122"/>
                 <a:cs typeface="Malgun Gothic" pitchFamily="34" charset="-120"/>
               </a:rPr>
-              <a:t>입력 필요: 테스트 계정 · 유선전화번호 · 통신판매업 신고(또는 면제) · 도메인 확정(dolfstory.com)</a:t>
+              <a:t>남은 입력: 유선전화번호 · 통신판매업 신고번호(또는 면제) — 결제창·비회원 구매·주문 저장은 라이브 반영 완료</a:t>
             </a:r>
             <a:endParaRPr lang="en-US" sz="1100" dirty="0"/>
           </a:p>

</xml_diff>